<commit_message>
Deck: final video link, Elson role Process & QA Lead (BFSI Operations)
</commit_message>
<xml_diff>
--- a/docs/submission/InvoiceSentinel-BKD-KUBO-Deck.pptx
+++ b/docs/submission/InvoiceSentinel-BKD-KUBO-Deck.pptx
@@ -3606,7 +3606,7 @@
                 </a:solidFill>
                 <a:latin typeface="Arial"/>
               </a:rPr>
-              <a:t>Members: Manuel III Ocaña (Product Lead &amp; Solution Architect) · Elson Mojica (Domain Lead, Finance &amp; QA)</a:t>
+              <a:t>Members: Manuel III Ocaña — Product Lead &amp; Solution Architect · Elson Mojica — Process &amp; QA Lead (BFSI Operations)</a:t>
             </a:r>
           </a:p>
           <a:p>
@@ -5848,7 +5848,7 @@
                 </a:solidFill>
                 <a:latin typeface="Arial"/>
               </a:rPr>
-              <a:t>     [VIDEO LINK]</a:t>
+              <a:t>     https://drive.google.com/file/d/1QeAfyMxYIUnmQdOuLhxhQRP4CmUfL67a/view</a:t>
             </a:r>
           </a:p>
           <a:p>

</xml_diff>